<commit_message>
Remove speaker notes from presentation
</commit_message>
<xml_diff>
--- a/BP_Study_Presentation.pptx
+++ b/BP_Study_Presentation.pptx
@@ -6,11 +6,11 @@
   </p:sldMasterIdLst>
   <p:sldIdLst>
     <p:sldId id="256" r:id="rId7"/>
-    <p:sldId id="257" r:id="rId9"/>
-    <p:sldId id="258" r:id="rId10"/>
-    <p:sldId id="259" r:id="rId11"/>
-    <p:sldId id="260" r:id="rId12"/>
-    <p:sldId id="261" r:id="rId13"/>
+    <p:sldId id="257" r:id="rId8"/>
+    <p:sldId id="258" r:id="rId9"/>
+    <p:sldId id="259" r:id="rId10"/>
+    <p:sldId id="260" r:id="rId11"/>
+    <p:sldId id="261" r:id="rId12"/>
   </p:sldIdLst>
   <p:sldSz cx="12191695" cy="6858000" type="screen4x3"/>
   <p:notesSz cx="6858000" cy="9144000"/>
@@ -110,776 +110,6 @@
     </a:lvl9pPr>
   </p:defaultTextStyle>
 </p:presentation>
-</file>
-
-<file path=ppt/notesMasters/notesMaster1.xml><?xml version="1.0" encoding="utf-8"?>
-<p:notesMaster xmlns:a="http://schemas.openxmlformats.org/drawingml/2006/main" xmlns:p="http://schemas.openxmlformats.org/presentationml/2006/main" xmlns:r="http://schemas.openxmlformats.org/officeDocument/2006/relationships">
-  <p:cSld>
-    <p:bg>
-      <p:bgRef idx="1001">
-        <a:schemeClr val="bg1"/>
-      </p:bgRef>
-    </p:bg>
-    <p:spTree>
-      <p:nvGrpSpPr>
-        <p:cNvPr id="1" name=""/>
-        <p:cNvGrpSpPr/>
-        <p:nvPr/>
-      </p:nvGrpSpPr>
-      <p:grpSpPr>
-        <a:xfrm>
-          <a:off x="0" y="0"/>
-          <a:ext cx="0" cy="0"/>
-          <a:chOff x="0" y="0"/>
-          <a:chExt cx="0" cy="0"/>
-        </a:xfrm>
-      </p:grpSpPr>
-      <p:sp>
-        <p:nvSpPr>
-          <p:cNvPr id="2" name="Header Placeholder 1"/>
-          <p:cNvSpPr>
-            <a:spLocks noGrp="1"/>
-          </p:cNvSpPr>
-          <p:nvPr>
-            <p:ph type="hdr" sz="quarter"/>
-          </p:nvPr>
-        </p:nvSpPr>
-        <p:spPr>
-          <a:xfrm>
-            <a:off x="0" y="0"/>
-            <a:ext cx="2971800" cy="457200"/>
-          </a:xfrm>
-          <a:prstGeom prst="rect">
-            <a:avLst/>
-          </a:prstGeom>
-        </p:spPr>
-        <p:txBody>
-          <a:bodyPr vert="horz" lIns="91440" tIns="45720" rIns="91440" bIns="45720" rtlCol="0"/>
-          <a:lstStyle>
-            <a:lvl1pPr algn="l">
-              <a:defRPr sz="1200"/>
-            </a:lvl1pPr>
-          </a:lstStyle>
-          <a:p>
-            <a:endParaRPr lang="en-US"/>
-          </a:p>
-        </p:txBody>
-      </p:sp>
-      <p:sp>
-        <p:nvSpPr>
-          <p:cNvPr id="3" name="Date Placeholder 2"/>
-          <p:cNvSpPr>
-            <a:spLocks noGrp="1"/>
-          </p:cNvSpPr>
-          <p:nvPr>
-            <p:ph type="dt" idx="1"/>
-          </p:nvPr>
-        </p:nvSpPr>
-        <p:spPr>
-          <a:xfrm>
-            <a:off x="3884613" y="0"/>
-            <a:ext cx="2971800" cy="457200"/>
-          </a:xfrm>
-          <a:prstGeom prst="rect">
-            <a:avLst/>
-          </a:prstGeom>
-        </p:spPr>
-        <p:txBody>
-          <a:bodyPr vert="horz" lIns="91440" tIns="45720" rIns="91440" bIns="45720" rtlCol="0"/>
-          <a:lstStyle>
-            <a:lvl1pPr algn="r">
-              <a:defRPr sz="1200"/>
-            </a:lvl1pPr>
-          </a:lstStyle>
-          <a:p>
-            <a:fld id="{0F89C1C7-3DCD-1040-A9CF-14679D8B5DDD}" type="datetimeFigureOut">
-              <a:rPr lang="en-US" smtClean="0"/>
-              <a:t>10/17/16</a:t>
-            </a:fld>
-            <a:endParaRPr lang="en-US"/>
-          </a:p>
-        </p:txBody>
-      </p:sp>
-      <p:sp>
-        <p:nvSpPr>
-          <p:cNvPr id="4" name="Slide Image Placeholder 3"/>
-          <p:cNvSpPr>
-            <a:spLocks noGrp="1" noRot="1" noChangeAspect="1"/>
-          </p:cNvSpPr>
-          <p:nvPr>
-            <p:ph type="sldImg" idx="2"/>
-          </p:nvPr>
-        </p:nvSpPr>
-        <p:spPr>
-          <a:xfrm>
-            <a:off x="1143000" y="685800"/>
-            <a:ext cx="4572000" cy="3429000"/>
-          </a:xfrm>
-          <a:prstGeom prst="rect">
-            <a:avLst/>
-          </a:prstGeom>
-          <a:noFill/>
-          <a:ln w="12700">
-            <a:solidFill>
-              <a:prstClr val="black"/>
-            </a:solidFill>
-          </a:ln>
-        </p:spPr>
-        <p:txBody>
-          <a:bodyPr vert="horz" lIns="91440" tIns="45720" rIns="91440" bIns="45720" rtlCol="0" anchor="ctr"/>
-          <a:lstStyle/>
-          <a:p>
-            <a:endParaRPr lang="en-US"/>
-          </a:p>
-        </p:txBody>
-      </p:sp>
-      <p:sp>
-        <p:nvSpPr>
-          <p:cNvPr id="5" name="Notes Placeholder 4"/>
-          <p:cNvSpPr>
-            <a:spLocks noGrp="1"/>
-          </p:cNvSpPr>
-          <p:nvPr>
-            <p:ph type="body" sz="quarter" idx="3"/>
-          </p:nvPr>
-        </p:nvSpPr>
-        <p:spPr>
-          <a:xfrm>
-            <a:off x="685800" y="4343400"/>
-            <a:ext cx="5486400" cy="4114800"/>
-          </a:xfrm>
-          <a:prstGeom prst="rect">
-            <a:avLst/>
-          </a:prstGeom>
-        </p:spPr>
-        <p:txBody>
-          <a:bodyPr vert="horz" lIns="91440" tIns="45720" rIns="91440" bIns="45720" rtlCol="0"/>
-          <a:lstStyle/>
-          <a:p>
-            <a:pPr lvl="0"/>
-            <a:r>
-              <a:rPr lang="en-US" smtClean="0"/>
-              <a:t>Click to edit Master text styles</a:t>
-            </a:r>
-          </a:p>
-          <a:p>
-            <a:pPr lvl="1"/>
-            <a:r>
-              <a:rPr lang="en-US" smtClean="0"/>
-              <a:t>Second level</a:t>
-            </a:r>
-          </a:p>
-          <a:p>
-            <a:pPr lvl="2"/>
-            <a:r>
-              <a:rPr lang="en-US" smtClean="0"/>
-              <a:t>Third level</a:t>
-            </a:r>
-          </a:p>
-          <a:p>
-            <a:pPr lvl="3"/>
-            <a:r>
-              <a:rPr lang="en-US" smtClean="0"/>
-              <a:t>Fourth level</a:t>
-            </a:r>
-          </a:p>
-          <a:p>
-            <a:pPr lvl="4"/>
-            <a:r>
-              <a:rPr lang="en-US" smtClean="0"/>
-              <a:t>Fifth level</a:t>
-            </a:r>
-            <a:endParaRPr lang="en-US"/>
-          </a:p>
-        </p:txBody>
-      </p:sp>
-      <p:sp>
-        <p:nvSpPr>
-          <p:cNvPr id="6" name="Footer Placeholder 5"/>
-          <p:cNvSpPr>
-            <a:spLocks noGrp="1"/>
-          </p:cNvSpPr>
-          <p:nvPr>
-            <p:ph type="ftr" sz="quarter" idx="4"/>
-          </p:nvPr>
-        </p:nvSpPr>
-        <p:spPr>
-          <a:xfrm>
-            <a:off x="0" y="8685213"/>
-            <a:ext cx="2971800" cy="457200"/>
-          </a:xfrm>
-          <a:prstGeom prst="rect">
-            <a:avLst/>
-          </a:prstGeom>
-        </p:spPr>
-        <p:txBody>
-          <a:bodyPr vert="horz" lIns="91440" tIns="45720" rIns="91440" bIns="45720" rtlCol="0" anchor="b"/>
-          <a:lstStyle>
-            <a:lvl1pPr algn="l">
-              <a:defRPr sz="1200"/>
-            </a:lvl1pPr>
-          </a:lstStyle>
-          <a:p>
-            <a:endParaRPr lang="en-US"/>
-          </a:p>
-        </p:txBody>
-      </p:sp>
-      <p:sp>
-        <p:nvSpPr>
-          <p:cNvPr id="7" name="Slide Number Placeholder 6"/>
-          <p:cNvSpPr>
-            <a:spLocks noGrp="1"/>
-          </p:cNvSpPr>
-          <p:nvPr>
-            <p:ph type="sldNum" sz="quarter" idx="5"/>
-          </p:nvPr>
-        </p:nvSpPr>
-        <p:spPr>
-          <a:xfrm>
-            <a:off x="3884613" y="8685213"/>
-            <a:ext cx="2971800" cy="457200"/>
-          </a:xfrm>
-          <a:prstGeom prst="rect">
-            <a:avLst/>
-          </a:prstGeom>
-        </p:spPr>
-        <p:txBody>
-          <a:bodyPr vert="horz" lIns="91440" tIns="45720" rIns="91440" bIns="45720" rtlCol="0" anchor="b"/>
-          <a:lstStyle>
-            <a:lvl1pPr algn="r">
-              <a:defRPr sz="1200"/>
-            </a:lvl1pPr>
-          </a:lstStyle>
-          <a:p>
-            <a:fld id="{BB5E49A5-4136-284D-997B-48E1D791AD67}" type="slidenum">
-              <a:rPr lang="en-US" smtClean="0"/>
-              <a:t>‹#›</a:t>
-            </a:fld>
-            <a:endParaRPr lang="en-US"/>
-          </a:p>
-        </p:txBody>
-      </p:sp>
-    </p:spTree>
-    <p:extLst>
-      <p:ext uri="{BB962C8B-B14F-4D97-AF65-F5344CB8AC3E}">
-        <p14:creationId xmlns:p14="http://schemas.microsoft.com/office/powerpoint/2010/main" val="2623252185"/>
-      </p:ext>
-    </p:extLst>
-  </p:cSld>
-  <p:clrMap bg1="lt1" tx1="dk1" bg2="lt2" tx2="dk2" accent1="accent1" accent2="accent2" accent3="accent3" accent4="accent4" accent5="accent5" accent6="accent6" hlink="hlink" folHlink="folHlink"/>
-  <p:notesStyle>
-    <a:lvl1pPr marL="0" algn="l" defTabSz="457200" rtl="0" eaLnBrk="1" latinLnBrk="0" hangingPunct="1">
-      <a:defRPr sz="1200" kern="1200">
-        <a:solidFill>
-          <a:schemeClr val="tx1"/>
-        </a:solidFill>
-        <a:latin typeface="+mn-lt"/>
-        <a:ea typeface="+mn-ea"/>
-        <a:cs typeface="+mn-cs"/>
-      </a:defRPr>
-    </a:lvl1pPr>
-    <a:lvl2pPr marL="457200" algn="l" defTabSz="457200" rtl="0" eaLnBrk="1" latinLnBrk="0" hangingPunct="1">
-      <a:defRPr sz="1200" kern="1200">
-        <a:solidFill>
-          <a:schemeClr val="tx1"/>
-        </a:solidFill>
-        <a:latin typeface="+mn-lt"/>
-        <a:ea typeface="+mn-ea"/>
-        <a:cs typeface="+mn-cs"/>
-      </a:defRPr>
-    </a:lvl2pPr>
-    <a:lvl3pPr marL="914400" algn="l" defTabSz="457200" rtl="0" eaLnBrk="1" latinLnBrk="0" hangingPunct="1">
-      <a:defRPr sz="1200" kern="1200">
-        <a:solidFill>
-          <a:schemeClr val="tx1"/>
-        </a:solidFill>
-        <a:latin typeface="+mn-lt"/>
-        <a:ea typeface="+mn-ea"/>
-        <a:cs typeface="+mn-cs"/>
-      </a:defRPr>
-    </a:lvl3pPr>
-    <a:lvl4pPr marL="1371600" algn="l" defTabSz="457200" rtl="0" eaLnBrk="1" latinLnBrk="0" hangingPunct="1">
-      <a:defRPr sz="1200" kern="1200">
-        <a:solidFill>
-          <a:schemeClr val="tx1"/>
-        </a:solidFill>
-        <a:latin typeface="+mn-lt"/>
-        <a:ea typeface="+mn-ea"/>
-        <a:cs typeface="+mn-cs"/>
-      </a:defRPr>
-    </a:lvl4pPr>
-    <a:lvl5pPr marL="1828800" algn="l" defTabSz="457200" rtl="0" eaLnBrk="1" latinLnBrk="0" hangingPunct="1">
-      <a:defRPr sz="1200" kern="1200">
-        <a:solidFill>
-          <a:schemeClr val="tx1"/>
-        </a:solidFill>
-        <a:latin typeface="+mn-lt"/>
-        <a:ea typeface="+mn-ea"/>
-        <a:cs typeface="+mn-cs"/>
-      </a:defRPr>
-    </a:lvl5pPr>
-    <a:lvl6pPr marL="2286000" algn="l" defTabSz="457200" rtl="0" eaLnBrk="1" latinLnBrk="0" hangingPunct="1">
-      <a:defRPr sz="1200" kern="1200">
-        <a:solidFill>
-          <a:schemeClr val="tx1"/>
-        </a:solidFill>
-        <a:latin typeface="+mn-lt"/>
-        <a:ea typeface="+mn-ea"/>
-        <a:cs typeface="+mn-cs"/>
-      </a:defRPr>
-    </a:lvl6pPr>
-    <a:lvl7pPr marL="2743200" algn="l" defTabSz="457200" rtl="0" eaLnBrk="1" latinLnBrk="0" hangingPunct="1">
-      <a:defRPr sz="1200" kern="1200">
-        <a:solidFill>
-          <a:schemeClr val="tx1"/>
-        </a:solidFill>
-        <a:latin typeface="+mn-lt"/>
-        <a:ea typeface="+mn-ea"/>
-        <a:cs typeface="+mn-cs"/>
-      </a:defRPr>
-    </a:lvl7pPr>
-    <a:lvl8pPr marL="3200400" algn="l" defTabSz="457200" rtl="0" eaLnBrk="1" latinLnBrk="0" hangingPunct="1">
-      <a:defRPr sz="1200" kern="1200">
-        <a:solidFill>
-          <a:schemeClr val="tx1"/>
-        </a:solidFill>
-        <a:latin typeface="+mn-lt"/>
-        <a:ea typeface="+mn-ea"/>
-        <a:cs typeface="+mn-cs"/>
-      </a:defRPr>
-    </a:lvl8pPr>
-    <a:lvl9pPr marL="3657600" algn="l" defTabSz="457200" rtl="0" eaLnBrk="1" latinLnBrk="0" hangingPunct="1">
-      <a:defRPr sz="1200" kern="1200">
-        <a:solidFill>
-          <a:schemeClr val="tx1"/>
-        </a:solidFill>
-        <a:latin typeface="+mn-lt"/>
-        <a:ea typeface="+mn-ea"/>
-        <a:cs typeface="+mn-cs"/>
-      </a:defRPr>
-    </a:lvl9pPr>
-  </p:notesStyle>
-</p:notesMaster>
-</file>
-
-<file path=ppt/notesSlides/notesSlide1.xml><?xml version="1.0" encoding="utf-8"?>
-<p:notes xmlns:a="http://schemas.openxmlformats.org/drawingml/2006/main" xmlns:p="http://schemas.openxmlformats.org/presentationml/2006/main" xmlns:r="http://schemas.openxmlformats.org/officeDocument/2006/relationships">
-  <p:cSld>
-    <p:spTree>
-      <p:nvGrpSpPr>
-        <p:cNvPr id="1" name=""/>
-        <p:cNvGrpSpPr/>
-        <p:nvPr/>
-      </p:nvGrpSpPr>
-      <p:grpSpPr>
-        <a:xfrm>
-          <a:off x="0" y="0"/>
-          <a:ext cx="0" cy="0"/>
-          <a:chOff x="0" y="0"/>
-          <a:chExt cx="0" cy="0"/>
-        </a:xfrm>
-      </p:grpSpPr>
-      <p:sp>
-        <p:nvSpPr>
-          <p:cNvPr id="2" name="Slide Image Placeholder 1"/>
-          <p:cNvSpPr>
-            <a:spLocks noGrp="1"/>
-          </p:cNvSpPr>
-          <p:nvPr>
-            <p:ph type="sldImg" idx="2"/>
-          </p:nvPr>
-        </p:nvSpPr>
-        <p:spPr/>
-      </p:sp>
-      <p:sp>
-        <p:nvSpPr>
-          <p:cNvPr id="3" name="Notes Placeholder 2"/>
-          <p:cNvSpPr>
-            <a:spLocks noGrp="1"/>
-          </p:cNvSpPr>
-          <p:nvPr>
-            <p:ph type="body" idx="3" sz="quarter"/>
-          </p:nvPr>
-        </p:nvSpPr>
-        <p:spPr/>
-        <p:txBody>
-          <a:bodyPr/>
-          <a:lstStyle/>
-          <a:p>
-            <a:r>
-              <a:t>Welcome and framing. Introduce the core question: does pairing produce with guidance change blood pressure outcomes, and does it matter whether that guidance is human or AI? Set up the stakes: dietitian time is expensive and limited, so if an AI assistant can capture even part of that benefit, it changes how food-as-medicine programs could scale. This talk covers the objective, methodology, key findings, and what it means going forward. Should take about a minute.</a:t>
-            </a:r>
-          </a:p>
-        </p:txBody>
-      </p:sp>
-      <p:sp>
-        <p:nvSpPr>
-          <p:cNvPr id="4" name="Slide Number Placeholder 3"/>
-          <p:cNvSpPr>
-            <a:spLocks noGrp="1"/>
-          </p:cNvSpPr>
-          <p:nvPr>
-            <p:ph type="sldNum" idx="5" sz="quarter"/>
-          </p:nvPr>
-        </p:nvSpPr>
-        <p:spPr/>
-      </p:sp>
-    </p:spTree>
-  </p:cSld>
-  <p:clrMapOvr>
-    <a:masterClrMapping/>
-  </p:clrMapOvr>
-</p:notes>
-</file>
-
-<file path=ppt/notesSlides/notesSlide2.xml><?xml version="1.0" encoding="utf-8"?>
-<p:notes xmlns:a="http://schemas.openxmlformats.org/drawingml/2006/main" xmlns:p="http://schemas.openxmlformats.org/presentationml/2006/main" xmlns:r="http://schemas.openxmlformats.org/officeDocument/2006/relationships">
-  <p:cSld>
-    <p:spTree>
-      <p:nvGrpSpPr>
-        <p:cNvPr id="1" name=""/>
-        <p:cNvGrpSpPr/>
-        <p:nvPr/>
-      </p:nvGrpSpPr>
-      <p:grpSpPr>
-        <a:xfrm>
-          <a:off x="0" y="0"/>
-          <a:ext cx="0" cy="0"/>
-          <a:chOff x="0" y="0"/>
-          <a:chExt cx="0" cy="0"/>
-        </a:xfrm>
-      </p:grpSpPr>
-      <p:sp>
-        <p:nvSpPr>
-          <p:cNvPr id="2" name="Slide Image Placeholder 1"/>
-          <p:cNvSpPr>
-            <a:spLocks noGrp="1"/>
-          </p:cNvSpPr>
-          <p:nvPr>
-            <p:ph type="sldImg" idx="2"/>
-          </p:nvPr>
-        </p:nvSpPr>
-        <p:spPr/>
-      </p:sp>
-      <p:sp>
-        <p:nvSpPr>
-          <p:cNvPr id="3" name="Notes Placeholder 2"/>
-          <p:cNvSpPr>
-            <a:spLocks noGrp="1"/>
-          </p:cNvSpPr>
-          <p:nvPr>
-            <p:ph type="body" idx="3" sz="quarter"/>
-          </p:nvPr>
-        </p:nvSpPr>
-        <p:spPr/>
-        <p:txBody>
-          <a:bodyPr/>
-          <a:lstStyle/>
-          <a:p>
-            <a:r>
-              <a:t>Walk through the abstract in plain terms: 300 people, three groups, real baseline health data with a synthetic study layer on top. The headline is that both guided groups beat control, and that holds even after statistically controlling for adherence. Then introduce the four hypotheses this talk will come back to and confirm or reject in the results section. Keep this to about 90 seconds; this slide is scene-setting, not the payoff.</a:t>
-            </a:r>
-          </a:p>
-        </p:txBody>
-      </p:sp>
-      <p:sp>
-        <p:nvSpPr>
-          <p:cNvPr id="4" name="Slide Number Placeholder 3"/>
-          <p:cNvSpPr>
-            <a:spLocks noGrp="1"/>
-          </p:cNvSpPr>
-          <p:nvPr>
-            <p:ph type="sldNum" idx="5" sz="quarter"/>
-          </p:nvPr>
-        </p:nvSpPr>
-        <p:spPr/>
-      </p:sp>
-    </p:spTree>
-  </p:cSld>
-  <p:clrMapOvr>
-    <a:masterClrMapping/>
-  </p:clrMapOvr>
-</p:notes>
-</file>
-
-<file path=ppt/notesSlides/notesSlide3.xml><?xml version="1.0" encoding="utf-8"?>
-<p:notes xmlns:a="http://schemas.openxmlformats.org/drawingml/2006/main" xmlns:p="http://schemas.openxmlformats.org/presentationml/2006/main" xmlns:r="http://schemas.openxmlformats.org/officeDocument/2006/relationships">
-  <p:cSld>
-    <p:spTree>
-      <p:nvGrpSpPr>
-        <p:cNvPr id="1" name=""/>
-        <p:cNvGrpSpPr/>
-        <p:nvPr/>
-      </p:nvGrpSpPr>
-      <p:grpSpPr>
-        <a:xfrm>
-          <a:off x="0" y="0"/>
-          <a:ext cx="0" cy="0"/>
-          <a:chOff x="0" y="0"/>
-          <a:chExt cx="0" cy="0"/>
-        </a:xfrm>
-      </p:grpSpPr>
-      <p:sp>
-        <p:nvSpPr>
-          <p:cNvPr id="2" name="Slide Image Placeholder 1"/>
-          <p:cNvSpPr>
-            <a:spLocks noGrp="1"/>
-          </p:cNvSpPr>
-          <p:nvPr>
-            <p:ph type="sldImg" idx="2"/>
-          </p:nvPr>
-        </p:nvSpPr>
-        <p:spPr/>
-      </p:sp>
-      <p:sp>
-        <p:nvSpPr>
-          <p:cNvPr id="3" name="Notes Placeholder 2"/>
-          <p:cNvSpPr>
-            <a:spLocks noGrp="1"/>
-          </p:cNvSpPr>
-          <p:nvPr>
-            <p:ph type="body" idx="3" sz="quarter"/>
-          </p:nvPr>
-        </p:nvSpPr>
-        <p:spPr/>
-        <p:txBody>
-          <a:bodyPr/>
-          <a:lstStyle/>
-          <a:p>
-            <a:r>
-              <a:t>This slide covers the four practical questions any technical reviewer will ask: where did the data come from, how was it cleaned, what methods were run, and why those methods specifically. Emphasize that the baseline health data is real (a 70,000-record cardiovascular dataset), while the study-design variables are synthetic because no real trial of this exact design exists yet. Explain briefly why ANCOVA matters: it is the tool that separates 'guidance works' from 'guided people just ate more.' Budget about 2 minutes here since it is the most technical slide.</a:t>
-            </a:r>
-          </a:p>
-        </p:txBody>
-      </p:sp>
-      <p:sp>
-        <p:nvSpPr>
-          <p:cNvPr id="4" name="Slide Number Placeholder 3"/>
-          <p:cNvSpPr>
-            <a:spLocks noGrp="1"/>
-          </p:cNvSpPr>
-          <p:nvPr>
-            <p:ph type="sldNum" idx="5" sz="quarter"/>
-          </p:nvPr>
-        </p:nvSpPr>
-        <p:spPr/>
-      </p:sp>
-    </p:spTree>
-  </p:cSld>
-  <p:clrMapOvr>
-    <a:masterClrMapping/>
-  </p:clrMapOvr>
-</p:notes>
-</file>
-
-<file path=ppt/notesSlides/notesSlide4.xml><?xml version="1.0" encoding="utf-8"?>
-<p:notes xmlns:a="http://schemas.openxmlformats.org/drawingml/2006/main" xmlns:p="http://schemas.openxmlformats.org/presentationml/2006/main" xmlns:r="http://schemas.openxmlformats.org/officeDocument/2006/relationships">
-  <p:cSld>
-    <p:spTree>
-      <p:nvGrpSpPr>
-        <p:cNvPr id="1" name=""/>
-        <p:cNvGrpSpPr/>
-        <p:nvPr/>
-      </p:nvGrpSpPr>
-      <p:grpSpPr>
-        <a:xfrm>
-          <a:off x="0" y="0"/>
-          <a:ext cx="0" cy="0"/>
-          <a:chOff x="0" y="0"/>
-          <a:chExt cx="0" cy="0"/>
-        </a:xfrm>
-      </p:grpSpPr>
-      <p:sp>
-        <p:nvSpPr>
-          <p:cNvPr id="2" name="Slide Image Placeholder 1"/>
-          <p:cNvSpPr>
-            <a:spLocks noGrp="1"/>
-          </p:cNvSpPr>
-          <p:nvPr>
-            <p:ph type="sldImg" idx="2"/>
-          </p:nvPr>
-        </p:nvSpPr>
-        <p:spPr/>
-      </p:sp>
-      <p:sp>
-        <p:nvSpPr>
-          <p:cNvPr id="3" name="Notes Placeholder 2"/>
-          <p:cNvSpPr>
-            <a:spLocks noGrp="1"/>
-          </p:cNvSpPr>
-          <p:nvPr>
-            <p:ph type="body" idx="3" sz="quarter"/>
-          </p:nvPr>
-        </p:nvSpPr>
-        <p:spPr/>
-        <p:txBody>
-          <a:bodyPr/>
-          <a:lstStyle/>
-          <a:p>
-            <a:r>
-              <a:t>Only two charts on this slide by design, to keep it uncluttered. The left chart is the headline result: guided arms drop blood pressure more than control, with Dietitian ahead of AI Assistant. The right chart answers 'why': adherence to the produce plan has a strong, clean linear relationship with the outcome, confirmed by testing linear against polynomial fits rather than assuming it. Point out that this is pooled across all 300 participants. Spend about 2 minutes, since this is the visual core of the talk.</a:t>
-            </a:r>
-          </a:p>
-        </p:txBody>
-      </p:sp>
-      <p:sp>
-        <p:nvSpPr>
-          <p:cNvPr id="4" name="Slide Number Placeholder 3"/>
-          <p:cNvSpPr>
-            <a:spLocks noGrp="1"/>
-          </p:cNvSpPr>
-          <p:nvPr>
-            <p:ph type="sldNum" idx="5" sz="quarter"/>
-          </p:nvPr>
-        </p:nvSpPr>
-        <p:spPr/>
-      </p:sp>
-    </p:spTree>
-  </p:cSld>
-  <p:clrMapOvr>
-    <a:masterClrMapping/>
-  </p:clrMapOvr>
-</p:notes>
-</file>
-
-<file path=ppt/notesSlides/notesSlide5.xml><?xml version="1.0" encoding="utf-8"?>
-<p:notes xmlns:a="http://schemas.openxmlformats.org/drawingml/2006/main" xmlns:p="http://schemas.openxmlformats.org/presentationml/2006/main" xmlns:r="http://schemas.openxmlformats.org/officeDocument/2006/relationships">
-  <p:cSld>
-    <p:spTree>
-      <p:nvGrpSpPr>
-        <p:cNvPr id="1" name=""/>
-        <p:cNvGrpSpPr/>
-        <p:nvPr/>
-      </p:nvGrpSpPr>
-      <p:grpSpPr>
-        <a:xfrm>
-          <a:off x="0" y="0"/>
-          <a:ext cx="0" cy="0"/>
-          <a:chOff x="0" y="0"/>
-          <a:chExt cx="0" cy="0"/>
-        </a:xfrm>
-      </p:grpSpPr>
-      <p:sp>
-        <p:nvSpPr>
-          <p:cNvPr id="2" name="Slide Image Placeholder 1"/>
-          <p:cNvSpPr>
-            <a:spLocks noGrp="1"/>
-          </p:cNvSpPr>
-          <p:nvPr>
-            <p:ph type="sldImg" idx="2"/>
-          </p:nvPr>
-        </p:nvSpPr>
-        <p:spPr/>
-      </p:sp>
-      <p:sp>
-        <p:nvSpPr>
-          <p:cNvPr id="3" name="Notes Placeholder 2"/>
-          <p:cNvSpPr>
-            <a:spLocks noGrp="1"/>
-          </p:cNvSpPr>
-          <p:nvPr>
-            <p:ph type="body" idx="3" sz="quarter"/>
-          </p:nvPr>
-        </p:nvSpPr>
-        <p:spPr/>
-        <p:txBody>
-          <a:bodyPr/>
-          <a:lstStyle/>
-          <a:p>
-            <a:r>
-              <a:t>This is the interpretation slide, not a repeat of the charts. Confirm which hypotheses held up and which were only partially supported, and be direct about H4: Random Forest wins, but the size of that win is modest, and the real relationship between adherence and outcome is linear, which is itself a finding worth stating plainly. Flag the honest limitations clearly: synthetic outcome data, a weaker diastolic model, and the causal-forest stretch goal that was not run. This transparency is what makes the study credible. About 2 minutes.</a:t>
-            </a:r>
-          </a:p>
-        </p:txBody>
-      </p:sp>
-      <p:sp>
-        <p:nvSpPr>
-          <p:cNvPr id="4" name="Slide Number Placeholder 3"/>
-          <p:cNvSpPr>
-            <a:spLocks noGrp="1"/>
-          </p:cNvSpPr>
-          <p:nvPr>
-            <p:ph type="sldNum" idx="5" sz="quarter"/>
-          </p:nvPr>
-        </p:nvSpPr>
-        <p:spPr/>
-      </p:sp>
-    </p:spTree>
-  </p:cSld>
-  <p:clrMapOvr>
-    <a:masterClrMapping/>
-  </p:clrMapOvr>
-</p:notes>
-</file>
-
-<file path=ppt/notesSlides/notesSlide6.xml><?xml version="1.0" encoding="utf-8"?>
-<p:notes xmlns:a="http://schemas.openxmlformats.org/drawingml/2006/main" xmlns:p="http://schemas.openxmlformats.org/presentationml/2006/main" xmlns:r="http://schemas.openxmlformats.org/officeDocument/2006/relationships">
-  <p:cSld>
-    <p:spTree>
-      <p:nvGrpSpPr>
-        <p:cNvPr id="1" name=""/>
-        <p:cNvGrpSpPr/>
-        <p:nvPr/>
-      </p:nvGrpSpPr>
-      <p:grpSpPr>
-        <a:xfrm>
-          <a:off x="0" y="0"/>
-          <a:ext cx="0" cy="0"/>
-          <a:chOff x="0" y="0"/>
-          <a:chExt cx="0" cy="0"/>
-        </a:xfrm>
-      </p:grpSpPr>
-      <p:sp>
-        <p:nvSpPr>
-          <p:cNvPr id="2" name="Slide Image Placeholder 1"/>
-          <p:cNvSpPr>
-            <a:spLocks noGrp="1"/>
-          </p:cNvSpPr>
-          <p:nvPr>
-            <p:ph type="sldImg" idx="2"/>
-          </p:nvPr>
-        </p:nvSpPr>
-        <p:spPr/>
-      </p:sp>
-      <p:sp>
-        <p:nvSpPr>
-          <p:cNvPr id="3" name="Notes Placeholder 2"/>
-          <p:cNvSpPr>
-            <a:spLocks noGrp="1"/>
-          </p:cNvSpPr>
-          <p:nvPr>
-            <p:ph type="body" idx="3" sz="quarter"/>
-          </p:nvPr>
-        </p:nvSpPr>
-        <p:spPr/>
-        <p:txBody>
-          <a:bodyPr/>
-          <a:lstStyle/>
-          <a:p>
-            <a:r>
-              <a:t>Close by tying the whole talk back to one sentence: it is not enough to hand someone food, the guidance layered on top is what drives the outcome, and that guidance does not have to come from a human every time. Walk through the three recommendations briefly, and be honest that the next real step is replication on real trial data since everything shown today rests on a synthetic outcome layer over a real baseline cohort. End on the closing line, then open for questions. About 1.5 to 2 minutes, leaving room for Q&amp;A within the 10 to 12 minute window.</a:t>
-            </a:r>
-          </a:p>
-        </p:txBody>
-      </p:sp>
-      <p:sp>
-        <p:nvSpPr>
-          <p:cNvPr id="4" name="Slide Number Placeholder 3"/>
-          <p:cNvSpPr>
-            <a:spLocks noGrp="1"/>
-          </p:cNvSpPr>
-          <p:nvPr>
-            <p:ph type="sldNum" idx="5" sz="quarter"/>
-          </p:nvPr>
-        </p:nvSpPr>
-        <p:spPr/>
-      </p:sp>
-    </p:spTree>
-  </p:cSld>
-  <p:clrMapOvr>
-    <a:masterClrMapping/>
-  </p:clrMapOvr>
-</p:notes>
 </file>
 
 <file path=ppt/slideLayouts/slideLayout1.xml><?xml version="1.0" encoding="utf-8"?>
@@ -9172,324 +8402,4 @@
   </a:objectDefaults>
   <a:extraClrSchemeLst/>
 </a:theme>
-</file>
-
-<file path=ppt/theme/theme2.xml><?xml version="1.0" encoding="utf-8"?>
-<a:theme xmlns:a="http://schemas.openxmlformats.org/drawingml/2006/main" name="Office Theme">
-  <a:themeElements>
-    <a:clrScheme name="Office">
-      <a:dk1>
-        <a:sysClr val="windowText" lastClr="000000"/>
-      </a:dk1>
-      <a:lt1>
-        <a:sysClr val="window" lastClr="FFFFFF"/>
-      </a:lt1>
-      <a:dk2>
-        <a:srgbClr val="1F497D"/>
-      </a:dk2>
-      <a:lt2>
-        <a:srgbClr val="EEECE1"/>
-      </a:lt2>
-      <a:accent1>
-        <a:srgbClr val="4F81BD"/>
-      </a:accent1>
-      <a:accent2>
-        <a:srgbClr val="C0504D"/>
-      </a:accent2>
-      <a:accent3>
-        <a:srgbClr val="9BBB59"/>
-      </a:accent3>
-      <a:accent4>
-        <a:srgbClr val="8064A2"/>
-      </a:accent4>
-      <a:accent5>
-        <a:srgbClr val="4BACC6"/>
-      </a:accent5>
-      <a:accent6>
-        <a:srgbClr val="F79646"/>
-      </a:accent6>
-      <a:hlink>
-        <a:srgbClr val="0000FF"/>
-      </a:hlink>
-      <a:folHlink>
-        <a:srgbClr val="800080"/>
-      </a:folHlink>
-    </a:clrScheme>
-    <a:fontScheme name="Office">
-      <a:majorFont>
-        <a:latin typeface="Calibri"/>
-        <a:ea typeface=""/>
-        <a:cs typeface=""/>
-        <a:font script="Jpan" typeface="ＭＳ Ｐゴシック"/>
-        <a:font script="Hang" typeface="맑은 고딕"/>
-        <a:font script="Hans" typeface="宋体"/>
-        <a:font script="Hant" typeface="新細明體"/>
-        <a:font script="Arab" typeface="Times New Roman"/>
-        <a:font script="Hebr" typeface="Times New Roman"/>
-        <a:font script="Thai" typeface="Angsana New"/>
-        <a:font script="Ethi" typeface="Nyala"/>
-        <a:font script="Beng" typeface="Vrinda"/>
-        <a:font script="Gujr" typeface="Shruti"/>
-        <a:font script="Khmr" typeface="MoolBoran"/>
-        <a:font script="Knda" typeface="Tunga"/>
-        <a:font script="Guru" typeface="Raavi"/>
-        <a:font script="Cans" typeface="Euphemia"/>
-        <a:font script="Cher" typeface="Plantagenet Cherokee"/>
-        <a:font script="Yiii" typeface="Microsoft Yi Baiti"/>
-        <a:font script="Tibt" typeface="Microsoft Himalaya"/>
-        <a:font script="Thaa" typeface="MV Boli"/>
-        <a:font script="Deva" typeface="Mangal"/>
-        <a:font script="Telu" typeface="Gautami"/>
-        <a:font script="Taml" typeface="Latha"/>
-        <a:font script="Syrc" typeface="Estrangelo Edessa"/>
-        <a:font script="Orya" typeface="Kalinga"/>
-        <a:font script="Mlym" typeface="Kartika"/>
-        <a:font script="Laoo" typeface="DokChampa"/>
-        <a:font script="Sinh" typeface="Iskoola Pota"/>
-        <a:font script="Mong" typeface="Mongolian Baiti"/>
-        <a:font script="Viet" typeface="Times New Roman"/>
-        <a:font script="Uigh" typeface="Microsoft Uighur"/>
-        <a:font script="Geor" typeface="Sylfaen"/>
-      </a:majorFont>
-      <a:minorFont>
-        <a:latin typeface="Calibri"/>
-        <a:ea typeface=""/>
-        <a:cs typeface=""/>
-        <a:font script="Jpan" typeface="ＭＳ Ｐゴシック"/>
-        <a:font script="Hang" typeface="맑은 고딕"/>
-        <a:font script="Hans" typeface="宋体"/>
-        <a:font script="Hant" typeface="新細明體"/>
-        <a:font script="Arab" typeface="Arial"/>
-        <a:font script="Hebr" typeface="Arial"/>
-        <a:font script="Thai" typeface="Cordia New"/>
-        <a:font script="Ethi" typeface="Nyala"/>
-        <a:font script="Beng" typeface="Vrinda"/>
-        <a:font script="Gujr" typeface="Shruti"/>
-        <a:font script="Khmr" typeface="DaunPenh"/>
-        <a:font script="Knda" typeface="Tunga"/>
-        <a:font script="Guru" typeface="Raavi"/>
-        <a:font script="Cans" typeface="Euphemia"/>
-        <a:font script="Cher" typeface="Plantagenet Cherokee"/>
-        <a:font script="Yiii" typeface="Microsoft Yi Baiti"/>
-        <a:font script="Tibt" typeface="Microsoft Himalaya"/>
-        <a:font script="Thaa" typeface="MV Boli"/>
-        <a:font script="Deva" typeface="Mangal"/>
-        <a:font script="Telu" typeface="Gautami"/>
-        <a:font script="Taml" typeface="Latha"/>
-        <a:font script="Syrc" typeface="Estrangelo Edessa"/>
-        <a:font script="Orya" typeface="Kalinga"/>
-        <a:font script="Mlym" typeface="Kartika"/>
-        <a:font script="Laoo" typeface="DokChampa"/>
-        <a:font script="Sinh" typeface="Iskoola Pota"/>
-        <a:font script="Mong" typeface="Mongolian Baiti"/>
-        <a:font script="Viet" typeface="Arial"/>
-        <a:font script="Uigh" typeface="Microsoft Uighur"/>
-        <a:font script="Geor" typeface="Sylfaen"/>
-      </a:minorFont>
-    </a:fontScheme>
-    <a:fmtScheme name="Office">
-      <a:fillStyleLst>
-        <a:solidFill>
-          <a:schemeClr val="phClr"/>
-        </a:solidFill>
-        <a:gradFill rotWithShape="1">
-          <a:gsLst>
-            <a:gs pos="0">
-              <a:schemeClr val="phClr">
-                <a:tint val="50000"/>
-                <a:satMod val="300000"/>
-              </a:schemeClr>
-            </a:gs>
-            <a:gs pos="35000">
-              <a:schemeClr val="phClr">
-                <a:tint val="37000"/>
-                <a:satMod val="300000"/>
-              </a:schemeClr>
-            </a:gs>
-            <a:gs pos="100000">
-              <a:schemeClr val="phClr">
-                <a:tint val="15000"/>
-                <a:satMod val="350000"/>
-              </a:schemeClr>
-            </a:gs>
-          </a:gsLst>
-          <a:lin ang="16200000" scaled="1"/>
-        </a:gradFill>
-        <a:gradFill rotWithShape="1">
-          <a:gsLst>
-            <a:gs pos="0">
-              <a:schemeClr val="phClr">
-                <a:tint val="100000"/>
-                <a:shade val="100000"/>
-                <a:satMod val="130000"/>
-              </a:schemeClr>
-            </a:gs>
-            <a:gs pos="100000">
-              <a:schemeClr val="phClr">
-                <a:tint val="50000"/>
-                <a:shade val="100000"/>
-                <a:satMod val="350000"/>
-              </a:schemeClr>
-            </a:gs>
-          </a:gsLst>
-          <a:lin ang="16200000" scaled="0"/>
-        </a:gradFill>
-      </a:fillStyleLst>
-      <a:lnStyleLst>
-        <a:ln w="9525" cap="flat" cmpd="sng" algn="ctr">
-          <a:solidFill>
-            <a:schemeClr val="phClr">
-              <a:shade val="95000"/>
-              <a:satMod val="105000"/>
-            </a:schemeClr>
-          </a:solidFill>
-          <a:prstDash val="solid"/>
-        </a:ln>
-        <a:ln w="25400" cap="flat" cmpd="sng" algn="ctr">
-          <a:solidFill>
-            <a:schemeClr val="phClr"/>
-          </a:solidFill>
-          <a:prstDash val="solid"/>
-        </a:ln>
-        <a:ln w="38100" cap="flat" cmpd="sng" algn="ctr">
-          <a:solidFill>
-            <a:schemeClr val="phClr"/>
-          </a:solidFill>
-          <a:prstDash val="solid"/>
-        </a:ln>
-      </a:lnStyleLst>
-      <a:effectStyleLst>
-        <a:effectStyle>
-          <a:effectLst>
-            <a:outerShdw blurRad="40000" dist="20000" dir="5400000" rotWithShape="0">
-              <a:srgbClr val="000000">
-                <a:alpha val="38000"/>
-              </a:srgbClr>
-            </a:outerShdw>
-          </a:effectLst>
-        </a:effectStyle>
-        <a:effectStyle>
-          <a:effectLst>
-            <a:outerShdw blurRad="40000" dist="23000" dir="5400000" rotWithShape="0">
-              <a:srgbClr val="000000">
-                <a:alpha val="35000"/>
-              </a:srgbClr>
-            </a:outerShdw>
-          </a:effectLst>
-        </a:effectStyle>
-        <a:effectStyle>
-          <a:effectLst>
-            <a:outerShdw blurRad="40000" dist="23000" dir="5400000" rotWithShape="0">
-              <a:srgbClr val="000000">
-                <a:alpha val="35000"/>
-              </a:srgbClr>
-            </a:outerShdw>
-          </a:effectLst>
-          <a:scene3d>
-            <a:camera prst="orthographicFront">
-              <a:rot lat="0" lon="0" rev="0"/>
-            </a:camera>
-            <a:lightRig rig="threePt" dir="t">
-              <a:rot lat="0" lon="0" rev="1200000"/>
-            </a:lightRig>
-          </a:scene3d>
-          <a:sp3d>
-            <a:bevelT w="63500" h="25400"/>
-          </a:sp3d>
-        </a:effectStyle>
-      </a:effectStyleLst>
-      <a:bgFillStyleLst>
-        <a:solidFill>
-          <a:schemeClr val="phClr"/>
-        </a:solidFill>
-        <a:gradFill rotWithShape="1">
-          <a:gsLst>
-            <a:gs pos="0">
-              <a:schemeClr val="phClr">
-                <a:tint val="40000"/>
-                <a:satMod val="350000"/>
-              </a:schemeClr>
-            </a:gs>
-            <a:gs pos="40000">
-              <a:schemeClr val="phClr">
-                <a:tint val="45000"/>
-                <a:shade val="99000"/>
-                <a:satMod val="350000"/>
-              </a:schemeClr>
-            </a:gs>
-            <a:gs pos="100000">
-              <a:schemeClr val="phClr">
-                <a:shade val="20000"/>
-                <a:satMod val="255000"/>
-              </a:schemeClr>
-            </a:gs>
-          </a:gsLst>
-          <a:path path="circle">
-            <a:fillToRect l="50000" t="-80000" r="50000" b="180000"/>
-          </a:path>
-        </a:gradFill>
-        <a:gradFill rotWithShape="1">
-          <a:gsLst>
-            <a:gs pos="0">
-              <a:schemeClr val="phClr">
-                <a:tint val="80000"/>
-                <a:satMod val="300000"/>
-              </a:schemeClr>
-            </a:gs>
-            <a:gs pos="100000">
-              <a:schemeClr val="phClr">
-                <a:shade val="30000"/>
-                <a:satMod val="200000"/>
-              </a:schemeClr>
-            </a:gs>
-          </a:gsLst>
-          <a:path path="circle">
-            <a:fillToRect l="50000" t="50000" r="50000" b="50000"/>
-          </a:path>
-        </a:gradFill>
-      </a:bgFillStyleLst>
-    </a:fmtScheme>
-  </a:themeElements>
-  <a:objectDefaults>
-    <a:spDef>
-      <a:spPr/>
-      <a:bodyPr/>
-      <a:lstStyle/>
-      <a:style>
-        <a:lnRef idx="1">
-          <a:schemeClr val="accent1"/>
-        </a:lnRef>
-        <a:fillRef idx="3">
-          <a:schemeClr val="accent1"/>
-        </a:fillRef>
-        <a:effectRef idx="2">
-          <a:schemeClr val="accent1"/>
-        </a:effectRef>
-        <a:fontRef idx="minor">
-          <a:schemeClr val="lt1"/>
-        </a:fontRef>
-      </a:style>
-    </a:spDef>
-    <a:lnDef>
-      <a:spPr/>
-      <a:bodyPr/>
-      <a:lstStyle/>
-      <a:style>
-        <a:lnRef idx="2">
-          <a:schemeClr val="accent1"/>
-        </a:lnRef>
-        <a:fillRef idx="0">
-          <a:schemeClr val="accent1"/>
-        </a:fillRef>
-        <a:effectRef idx="1">
-          <a:schemeClr val="accent1"/>
-        </a:effectRef>
-        <a:fontRef idx="minor">
-          <a:schemeClr val="tx1"/>
-        </a:fontRef>
-      </a:style>
-    </a:lnDef>
-  </a:objectDefaults>
-  <a:extraClrSchemeLst/>
-</a:theme>
 </file>
</xml_diff>

<commit_message>
Reconcile paper, presentation, and repo on cleaned data (N=296)
Data cleaning surfaced 4 rows with physiologically implausible
baseline BP readings (diastolic of 1000, systolic of 17), now
dropped in scripts/common.py so every downstream script and the
Colab notebook use the same cleaned N=296 sample.

- Regenerated all 11 figures, eda_summary.md, modeling_summary.md,
  and model_comparison.csv on the cleaned data
- Rewrote COMPREHENSIVE_RESEARCH_PAPER.md/.pdf with a new Data
  Cleaning subsection and every statistic updated to match
- Updated BP_Study_Presentation.pptx text and charts to match,
  including correcting a stat that reversed after cleaning
  (systolic vs. diastolic model performance under CV vs. holdout)
- Added notebooks/bp_study_colab.ipynb (full workflow for Colab)
- Removed scripts/04_build_report.py and 05_build_paper.py
  (generated superseded FINAL_REPORT/RESEARCH_PAPER docs that
  were never part of this repo)
</commit_message>
<xml_diff>
--- a/BP_Study_Presentation.pptx
+++ b/BP_Study_Presentation.pptx
@@ -4038,7 +4038,7 @@
                 </a:solidFill>
                 <a:latin typeface="Calibri"/>
               </a:rPr>
-              <a:t>300 participants, </a:t>
+              <a:t>296 participants, </a:t>
             </a:r>
             <a:r>
               <a:rPr sz="1350" b="0" i="0">
@@ -4047,7 +4047,7 @@
                 </a:solidFill>
                 <a:latin typeface="Calibri"/>
               </a:rPr>
-              <a:t>3 arms (Dietitian, AI Assistant, Control), 100 each.</a:t>
+              <a:t>3 arms (Dietitian, AI Assistant, Control), 99/99/98 after cleaning.</a:t>
             </a:r>
           </a:p>
           <a:p>
@@ -5020,7 +5020,7 @@
                 </a:solidFill>
                 <a:latin typeface="Calibri"/>
               </a:rPr>
-              <a:t>300 rows, 57 columns. </a:t>
+              <a:t>296 rows, 57 columns. </a:t>
             </a:r>
             <a:r>
               <a:rPr sz="1200" b="0" i="0">
@@ -5029,7 +5029,7 @@
                 </a:solidFill>
                 <a:latin typeface="Calibri"/>
               </a:rPr>
-              <a:t>100 participants per arm, no missing values.</a:t>
+              <a:t>99/99/98 participants per arm after cleaning, no missing values.</a:t>
             </a:r>
           </a:p>
           <a:p>
@@ -5280,7 +5280,7 @@
                 </a:solidFill>
                 <a:latin typeface="Calibri"/>
               </a:rPr>
-              <a:t>Leakage columns removed: </a:t>
+              <a:t>4 rows dropped: </a:t>
             </a:r>
             <a:r>
               <a:rPr sz="1200" b="0" i="0">
@@ -5289,7 +5289,7 @@
                 </a:solidFill>
                 <a:latin typeface="Calibri"/>
               </a:rPr>
-              <a:t>follow-up BP, participant ID excluded from model features.</a:t>
+              <a:t>physiologically impossible baseline BP readings (e.g. diastolic of 1000), likely data entry artifacts.</a:t>
             </a:r>
           </a:p>
           <a:p>
@@ -5317,7 +5317,7 @@
                 </a:solidFill>
                 <a:latin typeface="Calibri"/>
               </a:rPr>
-              <a:t>Preprocessing pipeline: </a:t>
+              <a:t>Leakage columns removed: </a:t>
             </a:r>
             <a:r>
               <a:rPr sz="1200" b="0" i="0">
@@ -5326,7 +5326,7 @@
                 </a:solidFill>
                 <a:latin typeface="Calibri"/>
               </a:rPr>
-              <a:t>StandardScaler on numerics, one-hot encoding on categoricals.</a:t>
+              <a:t>follow-up BP, participant ID excluded from model features.</a:t>
             </a:r>
           </a:p>
           <a:p>
@@ -5354,7 +5354,7 @@
                 </a:solidFill>
                 <a:latin typeface="Calibri"/>
               </a:rPr>
-              <a:t>Adherence kept as a covariate </a:t>
+              <a:t>Preprocessing pipeline: </a:t>
             </a:r>
             <a:r>
               <a:rPr sz="1200" b="0" i="0">
@@ -5363,7 +5363,7 @@
                 </a:solidFill>
                 <a:latin typeface="Calibri"/>
               </a:rPr>
-              <a:t>throughout, never averaged away.</a:t>
+              <a:t>StandardScaler on numerics, one-hot encoding on categoricals.</a:t>
             </a:r>
           </a:p>
         </p:txBody>
@@ -5846,7 +5846,7 @@
                 </a:solidFill>
                 <a:latin typeface="Calibri"/>
               </a:rPr>
-              <a:t>avoids picking a winner off one lucky split, with only 300 rows.</a:t>
+              <a:t>avoids picking a winner off one lucky split, with under 300 rows.</a:t>
             </a:r>
           </a:p>
           <a:p>
@@ -7176,7 +7176,7 @@
                 </a:solidFill>
                 <a:latin typeface="Calibri"/>
               </a:rPr>
-              <a:t>Diastolic modeling is weaker </a:t>
+              <a:t>Diastolic modeling is less stable: </a:t>
             </a:r>
             <a:r>
               <a:rPr sz="1300" b="0" i="0">
@@ -7185,7 +7185,7 @@
                 </a:solidFill>
                 <a:latin typeface="Calibri"/>
               </a:rPr>
-              <a:t>than systolic (held-out R² = 0.24 vs. 0.45); treat diastolic predictions with more caution.</a:t>
+              <a:t>5-fold CV favors systolic (R² 0.42 vs. 0.32), but a single holdout split flips the ranking, a sign of small-sample noise, not a real reversal.</a:t>
             </a:r>
           </a:p>
           <a:p>

</xml_diff>